<commit_message>
feat(presentation): redesign slide 1 with executive keynote title and 4-pillar architectural dossier
</commit_message>
<xml_diff>
--- a/Smart_Component_Storage_Presentation_v2.pptx
+++ b/Smart_Component_Storage_Presentation_v2.pptx
@@ -3191,8 +3191,8 @@
         </p:nvSpPr>
         <p:spPr>
           <a:xfrm>
-            <a:off x="731520" y="365760"/>
-            <a:ext cx="9144000" cy="292608"/>
+            <a:off x="731520" y="438912"/>
+            <a:ext cx="9601200" cy="292608"/>
           </a:xfrm>
           <a:prstGeom prst="rect">
             <a:avLst/>
@@ -3214,7 +3214,7 @@
               </a:defRPr>
             </a:pPr>
             <a:r>
-              <a:t>MAJOR PROJECT SPECIFICATION // EMBEDDED IOT &amp; CYBER-PHYSICAL SYSTEMS</a:t>
+              <a:t>PHYSICAL COMPUTING &amp; EMBEDDED SYSTEMS // CAPSTONE PROJECT 2026</a:t>
             </a:r>
           </a:p>
         </p:txBody>
@@ -3227,7 +3227,7 @@
         </p:nvSpPr>
         <p:spPr>
           <a:xfrm>
-            <a:off x="10241280" y="365760"/>
+            <a:off x="10241280" y="438912"/>
             <a:ext cx="1371600" cy="320040"/>
           </a:xfrm>
           <a:prstGeom prst="rect">
@@ -3263,8 +3263,8 @@
         </p:nvSpPr>
         <p:spPr>
           <a:xfrm>
-            <a:off x="731520" y="658368"/>
-            <a:ext cx="10789920" cy="1188720"/>
+            <a:off x="731520" y="749808"/>
+            <a:ext cx="10789920" cy="1097280"/>
           </a:xfrm>
           <a:prstGeom prst="rect">
             <a:avLst/>
@@ -3272,13 +3272,13 @@
           <a:noFill/>
         </p:spPr>
         <p:txBody>
-          <a:bodyPr wrap="none">
+          <a:bodyPr wrap="square">
             <a:spAutoFit/>
           </a:bodyPr>
           <a:lstStyle/>
           <a:p>
             <a:pPr>
-              <a:defRPr sz="3400" b="1">
+              <a:defRPr sz="3800" b="1">
                 <a:solidFill>
                   <a:srgbClr val="FFFFFF"/>
                 </a:solidFill>
@@ -3291,7 +3291,10 @@
           </a:p>
           <a:p>
             <a:pPr>
-              <a:defRPr sz="1500" b="1">
+              <a:spcBef>
+                <a:spcPts val="400"/>
+              </a:spcBef>
+              <a:defRPr sz="1550" b="1">
                 <a:solidFill>
                   <a:srgbClr val="0EA5E9"/>
                 </a:solidFill>
@@ -3306,14 +3309,57 @@
       </p:sp>
       <p:sp>
         <p:nvSpPr>
-          <p:cNvPr id="7" name="Rounded Rectangle 6"/>
+          <p:cNvPr id="7" name="Rectangle 6"/>
           <p:cNvSpPr/>
           <p:nvPr/>
         </p:nvSpPr>
         <p:spPr>
           <a:xfrm>
-            <a:off x="731520" y="1920240"/>
-            <a:ext cx="5120640" cy="4480560"/>
+            <a:off x="731520" y="2084831"/>
+            <a:ext cx="10728655" cy="27432"/>
+          </a:xfrm>
+          <a:prstGeom prst="rect">
+            <a:avLst/>
+          </a:prstGeom>
+          <a:solidFill>
+            <a:srgbClr val="06B6D4"/>
+          </a:solidFill>
+          <a:ln>
+            <a:noFill/>
+          </a:ln>
+        </p:spPr>
+        <p:style>
+          <a:lnRef idx="1">
+            <a:schemeClr val="accent1"/>
+          </a:lnRef>
+          <a:fillRef idx="3">
+            <a:schemeClr val="accent1"/>
+          </a:fillRef>
+          <a:effectRef idx="2">
+            <a:schemeClr val="accent1"/>
+          </a:effectRef>
+          <a:fontRef idx="minor">
+            <a:schemeClr val="lt1"/>
+          </a:fontRef>
+        </p:style>
+        <p:txBody>
+          <a:bodyPr rtlCol="0" anchor="ctr"/>
+          <a:lstStyle/>
+          <a:p>
+            <a:pPr algn="ctr"/>
+          </a:p>
+        </p:txBody>
+      </p:sp>
+      <p:sp>
+        <p:nvSpPr>
+          <p:cNvPr id="8" name="Rounded Rectangle 7"/>
+          <p:cNvSpPr/>
+          <p:nvPr/>
+        </p:nvSpPr>
+        <p:spPr>
+          <a:xfrm>
+            <a:off x="731520" y="2286000"/>
+            <a:ext cx="2523744" cy="1645920"/>
           </a:xfrm>
           <a:prstGeom prst="roundRect">
             <a:avLst/>
@@ -3351,50 +3397,14 @@
       </p:sp>
       <p:sp>
         <p:nvSpPr>
-          <p:cNvPr id="8" name="TextBox 7"/>
-          <p:cNvSpPr txBox="1"/>
-          <p:nvPr/>
-        </p:nvSpPr>
-        <p:spPr>
-          <a:xfrm>
-            <a:off x="914400" y="2011680"/>
-            <a:ext cx="4754880" cy="365760"/>
-          </a:xfrm>
-          <a:prstGeom prst="rect">
-            <a:avLst/>
-          </a:prstGeom>
-          <a:noFill/>
-        </p:spPr>
-        <p:txBody>
-          <a:bodyPr wrap="none">
-            <a:spAutoFit/>
-          </a:bodyPr>
-          <a:lstStyle/>
-          <a:p>
-            <a:pPr>
-              <a:defRPr sz="1100" b="1">
-                <a:solidFill>
-                  <a:srgbClr val="06B6D4"/>
-                </a:solidFill>
-                <a:latin typeface="Space Mono"/>
-              </a:defRPr>
-            </a:pPr>
-            <a:r>
-              <a:t>PROJECT METADATA &amp; SUBMITTER DETAILS</a:t>
-            </a:r>
-          </a:p>
-        </p:txBody>
-      </p:sp>
-      <p:sp>
-        <p:nvSpPr>
           <p:cNvPr id="9" name="TextBox 8"/>
           <p:cNvSpPr txBox="1"/>
           <p:nvPr/>
         </p:nvSpPr>
         <p:spPr>
           <a:xfrm>
-            <a:off x="914400" y="2377440"/>
-            <a:ext cx="4754880" cy="3840480"/>
+            <a:off x="841248" y="2377440"/>
+            <a:ext cx="2304288" cy="1463040"/>
           </a:xfrm>
           <a:prstGeom prst="rect">
             <a:avLst/>
@@ -3411,23 +3421,36 @@
               <a:spcAft>
                 <a:spcPts val="200"/>
               </a:spcAft>
-              <a:defRPr sz="1050" b="1">
+              <a:defRPr sz="950" b="1">
+                <a:solidFill>
+                  <a:srgbClr val="06B6D4"/>
+                </a:solidFill>
+                <a:latin typeface="Space Mono"/>
+              </a:defRPr>
+            </a:pPr>
+            <a:r>
+              <a:t>01 // 36-SLOT MATRIX</a:t>
+            </a:r>
+          </a:p>
+          <a:p>
+            <a:pPr>
+              <a:spcAft>
+                <a:spcPts val="400"/>
+              </a:spcAft>
+              <a:defRPr sz="1150" b="1">
                 <a:solidFill>
                   <a:srgbClr val="FFFFFF"/>
                 </a:solidFill>
-                <a:latin typeface="Space Mono"/>
-              </a:defRPr>
-            </a:pPr>
-            <a:r>
-              <a:t>PROJECT LEAD &amp; DEVELOPER</a:t>
-            </a:r>
-          </a:p>
-          <a:p>
-            <a:pPr>
-              <a:spcAft>
-                <a:spcPts val="800"/>
-              </a:spcAft>
-              <a:defRPr sz="1150">
+                <a:latin typeface="Syne"/>
+              </a:defRPr>
+            </a:pPr>
+            <a:r>
+              <a:t>Modular Hermetic Cells</a:t>
+            </a:r>
+          </a:p>
+          <a:p>
+            <a:pPr>
+              <a:defRPr sz="1000">
                 <a:solidFill>
                   <a:srgbClr val="94A3B8"/>
                 </a:solidFill>
@@ -3435,135 +3458,7 @@
               </a:defRPr>
             </a:pPr>
             <a:r>
-              <a:t>Shreyansh Agrawal (Lead System Architect &amp; Full-Stack IoT Engineer)</a:t>
-            </a:r>
-          </a:p>
-          <a:p>
-            <a:pPr>
-              <a:spcAft>
-                <a:spcPts val="200"/>
-              </a:spcAft>
-              <a:defRPr sz="1050" b="1">
-                <a:solidFill>
-                  <a:srgbClr val="FFFFFF"/>
-                </a:solidFill>
-                <a:latin typeface="Space Mono"/>
-              </a:defRPr>
-            </a:pPr>
-            <a:r>
-              <a:t>PROJECT DOMAIN &amp; TRACK</a:t>
-            </a:r>
-          </a:p>
-          <a:p>
-            <a:pPr>
-              <a:spcAft>
-                <a:spcPts val="800"/>
-              </a:spcAft>
-              <a:defRPr sz="1150">
-                <a:solidFill>
-                  <a:srgbClr val="94A3B8"/>
-                </a:solidFill>
-                <a:latin typeface="Outfit"/>
-              </a:defRPr>
-            </a:pPr>
-            <a:r>
-              <a:t>Internet of Things (IoT), Embedded Systems &amp; Microelectronics Quality Control</a:t>
-            </a:r>
-          </a:p>
-          <a:p>
-            <a:pPr>
-              <a:spcAft>
-                <a:spcPts val="200"/>
-              </a:spcAft>
-              <a:defRPr sz="1050" b="1">
-                <a:solidFill>
-                  <a:srgbClr val="06B6D4"/>
-                </a:solidFill>
-                <a:latin typeface="Space Mono"/>
-              </a:defRPr>
-            </a:pPr>
-            <a:r>
-              <a:t>SOURCE CODE REPOSITORY</a:t>
-            </a:r>
-          </a:p>
-          <a:p>
-            <a:pPr>
-              <a:spcAft>
-                <a:spcPts val="800"/>
-              </a:spcAft>
-              <a:defRPr sz="1150">
-                <a:solidFill>
-                  <a:srgbClr val="94A3B8"/>
-                </a:solidFill>
-                <a:latin typeface="Outfit"/>
-              </a:defRPr>
-            </a:pPr>
-            <a:r>
-              <a:t>GitHub: github.com/Shreyansha790/smart-component-storage (Branch: main)</a:t>
-            </a:r>
-          </a:p>
-          <a:p>
-            <a:pPr>
-              <a:spcAft>
-                <a:spcPts val="200"/>
-              </a:spcAft>
-              <a:defRPr sz="1050" b="1">
-                <a:solidFill>
-                  <a:srgbClr val="10B981"/>
-                </a:solidFill>
-                <a:latin typeface="Space Mono"/>
-              </a:defRPr>
-            </a:pPr>
-            <a:r>
-              <a:t>LIVE WEB DEPLOYMENT</a:t>
-            </a:r>
-          </a:p>
-          <a:p>
-            <a:pPr>
-              <a:spcAft>
-                <a:spcPts val="800"/>
-              </a:spcAft>
-              <a:defRPr sz="1150">
-                <a:solidFill>
-                  <a:srgbClr val="94A3B8"/>
-                </a:solidFill>
-                <a:latin typeface="Outfit"/>
-              </a:defRPr>
-            </a:pPr>
-            <a:r>
-              <a:t>Cloud Production: smart-component-storage.vercel.app (Cleanroom HUD)</a:t>
-            </a:r>
-          </a:p>
-          <a:p>
-            <a:pPr>
-              <a:spcAft>
-                <a:spcPts val="200"/>
-              </a:spcAft>
-              <a:defRPr sz="1050" b="1">
-                <a:solidFill>
-                  <a:srgbClr val="F59E0B"/>
-                </a:solidFill>
-                <a:latin typeface="Space Mono"/>
-              </a:defRPr>
-            </a:pPr>
-            <a:r>
-              <a:t>INDUSTRY STANDARDS</a:t>
-            </a:r>
-          </a:p>
-          <a:p>
-            <a:pPr>
-              <a:spcAft>
-                <a:spcPts val="800"/>
-              </a:spcAft>
-              <a:defRPr sz="1150">
-                <a:solidFill>
-                  <a:srgbClr val="94A3B8"/>
-                </a:solidFill>
-                <a:latin typeface="Outfit"/>
-              </a:defRPr>
-            </a:pPr>
-            <a:r>
-              <a:t>IPC/JEDEC J-STD-033 (Moisture Sensitivity) &amp; JEDEC JESD22-A108 (Arrhenius)</a:t>
+              <a:t>Hermetically isolated 6x6 compartments with perimeter silicone gaskets preventing microclimate cross-leakage.</a:t>
             </a:r>
           </a:p>
         </p:txBody>
@@ -3576,8 +3471,8 @@
         </p:nvSpPr>
         <p:spPr>
           <a:xfrm>
-            <a:off x="6126480" y="1920240"/>
-            <a:ext cx="5303520" cy="4480560"/>
+            <a:off x="3465576" y="2286000"/>
+            <a:ext cx="2523744" cy="1645920"/>
           </a:xfrm>
           <a:prstGeom prst="roundRect">
             <a:avLst/>
@@ -3621,44 +3516,8 @@
         </p:nvSpPr>
         <p:spPr>
           <a:xfrm>
-            <a:off x="6309360" y="2011680"/>
-            <a:ext cx="4937760" cy="365760"/>
-          </a:xfrm>
-          <a:prstGeom prst="rect">
-            <a:avLst/>
-          </a:prstGeom>
-          <a:noFill/>
-        </p:spPr>
-        <p:txBody>
-          <a:bodyPr wrap="none">
-            <a:spAutoFit/>
-          </a:bodyPr>
-          <a:lstStyle/>
-          <a:p>
-            <a:pPr>
-              <a:defRPr sz="1100" b="1">
-                <a:solidFill>
-                  <a:srgbClr val="06B6D4"/>
-                </a:solidFill>
-                <a:latin typeface="Space Mono"/>
-              </a:defRPr>
-            </a:pPr>
-            <a:r>
-              <a:t>EXECUTIVE SUMMARY &amp; CORE INNOVATIONS</a:t>
-            </a:r>
-          </a:p>
-        </p:txBody>
-      </p:sp>
-      <p:sp>
-        <p:nvSpPr>
-          <p:cNvPr id="12" name="TextBox 11"/>
-          <p:cNvSpPr txBox="1"/>
-          <p:nvPr/>
-        </p:nvSpPr>
-        <p:spPr>
-          <a:xfrm>
-            <a:off x="6309360" y="2377440"/>
-            <a:ext cx="4937760" cy="3840480"/>
+            <a:off x="3575304" y="2377440"/>
+            <a:ext cx="2304288" cy="1463040"/>
           </a:xfrm>
           <a:prstGeom prst="rect">
             <a:avLst/>
@@ -3673,25 +3532,9 @@
           <a:p>
             <a:pPr>
               <a:spcAft>
-                <a:spcPts val="1000"/>
-              </a:spcAft>
-              <a:defRPr sz="1100">
-                <a:solidFill>
-                  <a:srgbClr val="94A3B8"/>
-                </a:solidFill>
-                <a:latin typeface="Outfit"/>
-              </a:defRPr>
-            </a:pPr>
-            <a:r>
-              <a:t>Static cleanroom storage currently relies on passive cabinets and blind FIFO dispatch, allowing unmonitored thermal spikes to accelerate Kirkendall voiding and moisture popcorning. This project engineers a complete 36-compartment cyber-physical storage system that actively counters component degradation:</a:t>
-            </a:r>
-          </a:p>
-          <a:p>
-            <a:pPr>
-              <a:spcAft>
                 <a:spcPts val="200"/>
               </a:spcAft>
-              <a:defRPr sz="1050" b="1">
+              <a:defRPr sz="950" b="1">
                 <a:solidFill>
                   <a:srgbClr val="10B981"/>
                 </a:solidFill>
@@ -3699,71 +3542,7 @@
               </a:defRPr>
             </a:pPr>
             <a:r>
-              <a:t>1. KINETIC AGING INVERSION</a:t>
-            </a:r>
-          </a:p>
-          <a:p>
-            <a:pPr>
-              <a:spcAft>
-                <a:spcPts val="600"/>
-              </a:spcAft>
-              <a:defRPr sz="1150">
-                <a:solidFill>
-                  <a:srgbClr val="94A3B8"/>
-                </a:solidFill>
-                <a:latin typeface="Outfit"/>
-              </a:defRPr>
-            </a:pPr>
-            <a:r>
-              <a:t>Real-time numerical Arrhenius solver (Ea = 0.60 eV) dynamically adjusts component lifespan based on thermal-moisture history.</a:t>
-            </a:r>
-          </a:p>
-          <a:p>
-            <a:pPr>
-              <a:spcAft>
-                <a:spcPts val="200"/>
-              </a:spcAft>
-              <a:defRPr sz="1050" b="1">
-                <a:solidFill>
-                  <a:srgbClr val="06B6D4"/>
-                </a:solidFill>
-                <a:latin typeface="Space Mono"/>
-              </a:defRPr>
-            </a:pPr>
-            <a:r>
-              <a:t>2. CLOSED-LOOP REGULATION</a:t>
-            </a:r>
-          </a:p>
-          <a:p>
-            <a:pPr>
-              <a:spcAft>
-                <a:spcPts val="600"/>
-              </a:spcAft>
-              <a:defRPr sz="1150">
-                <a:solidFill>
-                  <a:srgbClr val="94A3B8"/>
-                </a:solidFill>
-                <a:latin typeface="Outfit"/>
-              </a:defRPr>
-            </a:pPr>
-            <a:r>
-              <a:t>ESP32 dual-core FreeRTOS manages Peltier cooling and servo ventilation to maintain &lt;5% RH and 20.0°C setpoint.</a:t>
-            </a:r>
-          </a:p>
-          <a:p>
-            <a:pPr>
-              <a:spcAft>
-                <a:spcPts val="200"/>
-              </a:spcAft>
-              <a:defRPr sz="1050" b="1">
-                <a:solidFill>
-                  <a:srgbClr val="F59E0B"/>
-                </a:solidFill>
-                <a:latin typeface="Space Mono"/>
-              </a:defRPr>
-            </a:pPr>
-            <a:r>
-              <a:t>3. DYNAMIC FEFO ENGINE</a:t>
+              <a:t>02 // ARRHENIUS KINETICS</a:t>
             </a:r>
           </a:p>
           <a:p>
@@ -3771,7 +3550,20 @@
               <a:spcAft>
                 <a:spcPts val="400"/>
               </a:spcAft>
-              <a:defRPr sz="1150">
+              <a:defRPr sz="1150" b="1">
+                <a:solidFill>
+                  <a:srgbClr val="FFFFFF"/>
+                </a:solidFill>
+                <a:latin typeface="Syne"/>
+              </a:defRPr>
+            </a:pPr>
+            <a:r>
+              <a:t>Ea = 0.60 eV Physics Engine</a:t>
+            </a:r>
+          </a:p>
+          <a:p>
+            <a:pPr>
+              <a:defRPr sz="1000">
                 <a:solidFill>
                   <a:srgbClr val="94A3B8"/>
                 </a:solidFill>
@@ -3779,31 +3571,31 @@
               </a:defRPr>
             </a:pPr>
             <a:r>
-              <a:t>Automatically routes thermally stressed inventory to assembly lines first, preventing premature field failures.</a:t>
-            </a:r>
-          </a:p>
-        </p:txBody>
-      </p:sp>
-      <p:sp>
-        <p:nvSpPr>
-          <p:cNvPr id="13" name="Rounded Rectangle 12"/>
+              <a:t>Embedded numerical solver continuously integrating thermal excursions into dynamic component shelf-life derating.</a:t>
+            </a:r>
+          </a:p>
+        </p:txBody>
+      </p:sp>
+      <p:sp>
+        <p:nvSpPr>
+          <p:cNvPr id="12" name="Rounded Rectangle 11"/>
           <p:cNvSpPr/>
           <p:nvPr/>
         </p:nvSpPr>
         <p:spPr>
           <a:xfrm>
-            <a:off x="731520" y="6355080"/>
-            <a:ext cx="3291840" cy="320040"/>
+            <a:off x="6199632" y="2286000"/>
+            <a:ext cx="2523744" cy="1645920"/>
           </a:xfrm>
           <a:prstGeom prst="roundRect">
             <a:avLst/>
           </a:prstGeom>
           <a:solidFill>
-            <a:srgbClr val="0F172A"/>
+            <a:srgbClr val="11182B"/>
           </a:solidFill>
-          <a:ln w="9525">
+          <a:ln w="12700">
             <a:solidFill>
-              <a:srgbClr val="06B6D4"/>
+              <a:srgbClr val="1E2945"/>
             </a:solidFill>
           </a:ln>
         </p:spPr>
@@ -3822,19 +3614,77 @@
           </a:fontRef>
         </p:style>
         <p:txBody>
-          <a:bodyPr rtlCol="0" anchor="ctr" wrap="square"/>
-          <a:lstStyle/>
-          <a:p>
-            <a:pPr algn="ctr">
-              <a:defRPr sz="850" b="1">
-                <a:solidFill>
-                  <a:srgbClr val="06B6D4"/>
+          <a:bodyPr rtlCol="0" anchor="ctr"/>
+          <a:lstStyle/>
+          <a:p>
+            <a:pPr algn="ctr"/>
+          </a:p>
+        </p:txBody>
+      </p:sp>
+      <p:sp>
+        <p:nvSpPr>
+          <p:cNvPr id="13" name="TextBox 12"/>
+          <p:cNvSpPr txBox="1"/>
+          <p:nvPr/>
+        </p:nvSpPr>
+        <p:spPr>
+          <a:xfrm>
+            <a:off x="6309360" y="2377440"/>
+            <a:ext cx="2304288" cy="1463040"/>
+          </a:xfrm>
+          <a:prstGeom prst="rect">
+            <a:avLst/>
+          </a:prstGeom>
+          <a:noFill/>
+        </p:spPr>
+        <p:txBody>
+          <a:bodyPr wrap="square">
+            <a:spAutoFit/>
+          </a:bodyPr>
+          <a:lstStyle/>
+          <a:p>
+            <a:pPr>
+              <a:spcAft>
+                <a:spcPts val="200"/>
+              </a:spcAft>
+              <a:defRPr sz="950" b="1">
+                <a:solidFill>
+                  <a:srgbClr val="F59E0B"/>
                 </a:solidFill>
                 <a:latin typeface="Space Mono"/>
               </a:defRPr>
             </a:pPr>
             <a:r>
-              <a:t>AUTHOR: SHREYANSH AGRAWAL</a:t>
+              <a:t>03 // CLIMATE CONTROL</a:t>
+            </a:r>
+          </a:p>
+          <a:p>
+            <a:pPr>
+              <a:spcAft>
+                <a:spcPts val="400"/>
+              </a:spcAft>
+              <a:defRPr sz="1150" b="1">
+                <a:solidFill>
+                  <a:srgbClr val="FFFFFF"/>
+                </a:solidFill>
+                <a:latin typeface="Syne"/>
+              </a:defRPr>
+            </a:pPr>
+            <a:r>
+              <a:t>Closed-Loop Peltier Cooling</a:t>
+            </a:r>
+          </a:p>
+          <a:p>
+            <a:pPr>
+              <a:defRPr sz="1000">
+                <a:solidFill>
+                  <a:srgbClr val="94A3B8"/>
+                </a:solidFill>
+                <a:latin typeface="Outfit"/>
+              </a:defRPr>
+            </a:pPr>
+            <a:r>
+              <a:t>Active thermoelectric cooling and desiccant regulation sustaining &lt;5% RH and 20.0°C ± 0.5°C chamber stability.</a:t>
             </a:r>
           </a:p>
         </p:txBody>
@@ -3847,18 +3697,18 @@
         </p:nvSpPr>
         <p:spPr>
           <a:xfrm>
-            <a:off x="4206240" y="6355080"/>
-            <a:ext cx="3566160" cy="320040"/>
+            <a:off x="8933688" y="2286000"/>
+            <a:ext cx="2523744" cy="1645920"/>
           </a:xfrm>
           <a:prstGeom prst="roundRect">
             <a:avLst/>
           </a:prstGeom>
           <a:solidFill>
-            <a:srgbClr val="0F172A"/>
+            <a:srgbClr val="11182B"/>
           </a:solidFill>
-          <a:ln w="9525">
+          <a:ln w="12700">
             <a:solidFill>
-              <a:srgbClr val="10B981"/>
+              <a:srgbClr val="1E2945"/>
             </a:solidFill>
           </a:ln>
         </p:spPr>
@@ -3877,43 +3727,101 @@
           </a:fontRef>
         </p:style>
         <p:txBody>
-          <a:bodyPr rtlCol="0" anchor="ctr" wrap="square"/>
-          <a:lstStyle/>
-          <a:p>
-            <a:pPr algn="ctr">
-              <a:defRPr sz="850" b="1">
-                <a:solidFill>
-                  <a:srgbClr val="10B981"/>
+          <a:bodyPr rtlCol="0" anchor="ctr"/>
+          <a:lstStyle/>
+          <a:p>
+            <a:pPr algn="ctr"/>
+          </a:p>
+        </p:txBody>
+      </p:sp>
+      <p:sp>
+        <p:nvSpPr>
+          <p:cNvPr id="15" name="TextBox 14"/>
+          <p:cNvSpPr txBox="1"/>
+          <p:nvPr/>
+        </p:nvSpPr>
+        <p:spPr>
+          <a:xfrm>
+            <a:off x="9043416" y="2377440"/>
+            <a:ext cx="2304288" cy="1463040"/>
+          </a:xfrm>
+          <a:prstGeom prst="rect">
+            <a:avLst/>
+          </a:prstGeom>
+          <a:noFill/>
+        </p:spPr>
+        <p:txBody>
+          <a:bodyPr wrap="square">
+            <a:spAutoFit/>
+          </a:bodyPr>
+          <a:lstStyle/>
+          <a:p>
+            <a:pPr>
+              <a:spcAft>
+                <a:spcPts val="200"/>
+              </a:spcAft>
+              <a:defRPr sz="950" b="1">
+                <a:solidFill>
+                  <a:srgbClr val="F43F5E"/>
                 </a:solidFill>
                 <a:latin typeface="Space Mono"/>
               </a:defRPr>
             </a:pPr>
             <a:r>
-              <a:t>STATUS: VERIFIED &amp; TESTED (36/36 PASS)</a:t>
-            </a:r>
-          </a:p>
-        </p:txBody>
-      </p:sp>
-      <p:sp>
-        <p:nvSpPr>
-          <p:cNvPr id="15" name="Rounded Rectangle 14"/>
+              <a:t>04 // FEFO DISPATCH</a:t>
+            </a:r>
+          </a:p>
+          <a:p>
+            <a:pPr>
+              <a:spcAft>
+                <a:spcPts val="400"/>
+              </a:spcAft>
+              <a:defRPr sz="1150" b="1">
+                <a:solidFill>
+                  <a:srgbClr val="FFFFFF"/>
+                </a:solidFill>
+                <a:latin typeface="Syne"/>
+              </a:defRPr>
+            </a:pPr>
+            <a:r>
+              <a:t>Dynamic Priority Queue</a:t>
+            </a:r>
+          </a:p>
+          <a:p>
+            <a:pPr>
+              <a:defRPr sz="1000">
+                <a:solidFill>
+                  <a:srgbClr val="94A3B8"/>
+                </a:solidFill>
+                <a:latin typeface="Outfit"/>
+              </a:defRPr>
+            </a:pPr>
+            <a:r>
+              <a:t>Automated priority scheduling routing thermally stressed inventory to SMT assembly lines first to eliminate field defects.</a:t>
+            </a:r>
+          </a:p>
+        </p:txBody>
+      </p:sp>
+      <p:sp>
+        <p:nvSpPr>
+          <p:cNvPr id="16" name="Rounded Rectangle 15"/>
           <p:cNvSpPr/>
           <p:nvPr/>
         </p:nvSpPr>
         <p:spPr>
           <a:xfrm>
-            <a:off x="7955279" y="6355080"/>
-            <a:ext cx="3474720" cy="320040"/>
+            <a:off x="731520" y="4114800"/>
+            <a:ext cx="10728655" cy="2240280"/>
           </a:xfrm>
           <a:prstGeom prst="roundRect">
             <a:avLst/>
           </a:prstGeom>
           <a:solidFill>
-            <a:srgbClr val="0F172A"/>
+            <a:srgbClr val="11182B"/>
           </a:solidFill>
-          <a:ln w="9525">
+          <a:ln w="12700">
             <a:solidFill>
-              <a:srgbClr val="F59E0B"/>
+              <a:srgbClr val="1E2945"/>
             </a:solidFill>
           </a:ln>
         </p:spPr>
@@ -3932,11 +3840,192 @@
           </a:fontRef>
         </p:style>
         <p:txBody>
-          <a:bodyPr rtlCol="0" anchor="ctr" wrap="square"/>
-          <a:lstStyle/>
-          <a:p>
-            <a:pPr algn="ctr">
-              <a:defRPr sz="850" b="1">
+          <a:bodyPr rtlCol="0" anchor="ctr"/>
+          <a:lstStyle/>
+          <a:p>
+            <a:pPr algn="ctr"/>
+          </a:p>
+        </p:txBody>
+      </p:sp>
+      <p:sp>
+        <p:nvSpPr>
+          <p:cNvPr id="17" name="TextBox 16"/>
+          <p:cNvSpPr txBox="1"/>
+          <p:nvPr/>
+        </p:nvSpPr>
+        <p:spPr>
+          <a:xfrm>
+            <a:off x="960120" y="4279392"/>
+            <a:ext cx="3383280" cy="1920240"/>
+          </a:xfrm>
+          <a:prstGeom prst="rect">
+            <a:avLst/>
+          </a:prstGeom>
+          <a:noFill/>
+        </p:spPr>
+        <p:txBody>
+          <a:bodyPr wrap="square">
+            <a:spAutoFit/>
+          </a:bodyPr>
+          <a:lstStyle/>
+          <a:p>
+            <a:pPr>
+              <a:spcAft>
+                <a:spcPts val="400"/>
+              </a:spcAft>
+              <a:defRPr sz="1000" b="1">
+                <a:solidFill>
+                  <a:srgbClr val="06B6D4"/>
+                </a:solidFill>
+                <a:latin typeface="Space Mono"/>
+              </a:defRPr>
+            </a:pPr>
+            <a:r>
+              <a:t>PROJECT LEAD &amp; AUTHORSHIP</a:t>
+            </a:r>
+          </a:p>
+          <a:p>
+            <a:pPr>
+              <a:spcAft>
+                <a:spcPts val="200"/>
+              </a:spcAft>
+              <a:defRPr sz="1400" b="1">
+                <a:solidFill>
+                  <a:srgbClr val="FFFFFF"/>
+                </a:solidFill>
+                <a:latin typeface="Syne"/>
+              </a:defRPr>
+            </a:pPr>
+            <a:r>
+              <a:t>Shreyansh Agrawal</a:t>
+            </a:r>
+          </a:p>
+          <a:p>
+            <a:pPr>
+              <a:defRPr sz="1050">
+                <a:solidFill>
+                  <a:srgbClr val="94A3B8"/>
+                </a:solidFill>
+                <a:latin typeface="Outfit"/>
+              </a:defRPr>
+            </a:pPr>
+            <a:r>
+              <a:t>Lead System Architect &amp; Full-Stack IoT Engineer</a:t>
+            </a:r>
+            <a:br/>
+            <a:r>
+              <a:t>Specialization: Embedded Systems &amp; Semiconductor QA</a:t>
+            </a:r>
+            <a:br/>
+            <a:r>
+              <a:t>Academic Session: Final Capstone Review 2026</a:t>
+            </a:r>
+          </a:p>
+        </p:txBody>
+      </p:sp>
+      <p:sp>
+        <p:nvSpPr>
+          <p:cNvPr id="18" name="TextBox 17"/>
+          <p:cNvSpPr txBox="1"/>
+          <p:nvPr/>
+        </p:nvSpPr>
+        <p:spPr>
+          <a:xfrm>
+            <a:off x="4617720" y="4279392"/>
+            <a:ext cx="3383280" cy="1920240"/>
+          </a:xfrm>
+          <a:prstGeom prst="rect">
+            <a:avLst/>
+          </a:prstGeom>
+          <a:noFill/>
+        </p:spPr>
+        <p:txBody>
+          <a:bodyPr wrap="square">
+            <a:spAutoFit/>
+          </a:bodyPr>
+          <a:lstStyle/>
+          <a:p>
+            <a:pPr>
+              <a:spcAft>
+                <a:spcPts val="400"/>
+              </a:spcAft>
+              <a:defRPr sz="1000" b="1">
+                <a:solidFill>
+                  <a:srgbClr val="10B981"/>
+                </a:solidFill>
+                <a:latin typeface="Space Mono"/>
+              </a:defRPr>
+            </a:pPr>
+            <a:r>
+              <a:t>HARDWARE CORE &amp; STANDARDS</a:t>
+            </a:r>
+          </a:p>
+          <a:p>
+            <a:pPr>
+              <a:spcAft>
+                <a:spcPts val="200"/>
+              </a:spcAft>
+              <a:defRPr sz="1200" b="1">
+                <a:solidFill>
+                  <a:srgbClr val="FFFFFF"/>
+                </a:solidFill>
+                <a:latin typeface="Syne"/>
+              </a:defRPr>
+            </a:pPr>
+            <a:r>
+              <a:t>ESP32 Dual-Core (FreeRTOS) @ 240MHz</a:t>
+            </a:r>
+          </a:p>
+          <a:p>
+            <a:pPr>
+              <a:defRPr sz="1050">
+                <a:solidFill>
+                  <a:srgbClr val="94A3B8"/>
+                </a:solidFill>
+                <a:latin typeface="Outfit"/>
+              </a:defRPr>
+            </a:pPr>
+            <a:r>
+              <a:t>Standards: IPC/JEDEC J-STD-033 &amp; JESD22-A108</a:t>
+            </a:r>
+            <a:br/>
+            <a:r>
+              <a:t>Security: HMAC-SHA256 Authenticated Telemetry</a:t>
+            </a:r>
+            <a:br/>
+            <a:r>
+              <a:t>Verification: 36/36 Automated Test Suites Passed</a:t>
+            </a:r>
+          </a:p>
+        </p:txBody>
+      </p:sp>
+      <p:sp>
+        <p:nvSpPr>
+          <p:cNvPr id="19" name="TextBox 18"/>
+          <p:cNvSpPr txBox="1"/>
+          <p:nvPr/>
+        </p:nvSpPr>
+        <p:spPr>
+          <a:xfrm>
+            <a:off x="8275320" y="4279392"/>
+            <a:ext cx="3383280" cy="1920240"/>
+          </a:xfrm>
+          <a:prstGeom prst="rect">
+            <a:avLst/>
+          </a:prstGeom>
+          <a:noFill/>
+        </p:spPr>
+        <p:txBody>
+          <a:bodyPr wrap="square">
+            <a:spAutoFit/>
+          </a:bodyPr>
+          <a:lstStyle/>
+          <a:p>
+            <a:pPr>
+              <a:spcAft>
+                <a:spcPts val="400"/>
+              </a:spcAft>
+              <a:defRPr sz="1000" b="1">
                 <a:solidFill>
                   <a:srgbClr val="F59E0B"/>
                 </a:solidFill>
@@ -3944,7 +4033,44 @@
               </a:defRPr>
             </a:pPr>
             <a:r>
-              <a:t>SESSION: CAPSTONE REVIEW 2026</a:t>
+              <a:t>PRODUCTION REPOSITORY &amp; CLOUD HUD</a:t>
+            </a:r>
+          </a:p>
+          <a:p>
+            <a:pPr>
+              <a:spcAft>
+                <a:spcPts val="200"/>
+              </a:spcAft>
+              <a:defRPr sz="1050" b="1">
+                <a:solidFill>
+                  <a:srgbClr val="06B6D4"/>
+                </a:solidFill>
+                <a:latin typeface="Space Mono"/>
+              </a:defRPr>
+            </a:pPr>
+            <a:r>
+              <a:t>github.com/Shreyansha790/smart-component-storage</a:t>
+            </a:r>
+          </a:p>
+          <a:p>
+            <a:pPr>
+              <a:defRPr sz="1050">
+                <a:solidFill>
+                  <a:srgbClr val="94A3B8"/>
+                </a:solidFill>
+                <a:latin typeface="Outfit"/>
+              </a:defRPr>
+            </a:pPr>
+            <a:r>
+              <a:t>Live Deployment: smart-component-storage.vercel.app</a:t>
+            </a:r>
+            <a:br/>
+            <a:r>
+              <a:t>Stack: Next.js 14 + Three.js + SQLite WAL + WebSockets</a:t>
+            </a:r>
+            <a:br/>
+            <a:r>
+              <a:t>Latency: Sub-15ms Bidirectional Control Pipeline</a:t>
             </a:r>
           </a:p>
         </p:txBody>

</xml_diff>